<commit_message>
Combined adult cohort 20-69y (AUX1 1999-2000 + AUX_G 2011-12 + AUX_I 2015-16)
User-directed switch: use the NHANES primary audiometry cycles that
actually test working-age adults (20-69 y). The 2017-2020 P_AUX cycle
only tests 6-19 and 70+.

- 10,889 adults (1,807 + 4,500 + 4,582); 19,568 clean ears from 9,832;
  train 15,654 / test 3,914
- Metrics: kappa 0.73, overall 92.3%, clear 96.9%, borderline 70.6%
  (18.8% of test ears), MAE 6.1 dB, rho 0.58 (range-restricted),
  Bland-Altman bias -1.1 dB (LoA -16.6..14.3, n=3,787)
- Distance curve 72.4% (<=1dB) -> 96.9% clear
- ML comparators still kappa ~0.98 (reference-in-disguise)
- eda/eda_report_combined.{pdf,docx,qmd}: complete combined-cycle EDA
  (fixed canonical-array PTA bug in EDA builder; borderline 18.2% full)
- All docs/figures/tables/deck/cover letter re-rendered + verified
- Figures: combined Bland-Altman, boundary-distance, config, EDA set
- New data files: /opt/data/AUX*.xpt + DEMO*.xpt (3 cycles)
</commit_message>
<xml_diff>
--- a/arabcic2026/arabcic2026_fuzzy_audiogram.pptx
+++ b/arabcic2026/arabcic2026_fuzzy_audiogram.pptx
@@ -586,7 +586,7 @@
           <a:lstStyle/>
           <a:p>
             <a:r>
-              <a:t>Configuration typing is an exploratory output: the adult cohort is predominantly steeply and gently sloping, and the fuzzy shape rules emit a six-category membership vector. Asymmetry affects 6.7% of the adult cohort at the 15 dB threshold, and the fuzzy index quantifies it continuously.</a:t>
+              <a:t>Configuration typing is an exploratory output: the combined adult cohort is predominantly flat and gently sloping, and the fuzzy shape rules emit a six-category membership vector. Asymmetry affects 5.1% of the cohort at the 15 dB threshold, and the fuzzy index quantifies it continuously.</a:t>
             </a:r>
           </a:p>
         </p:txBody>
@@ -1356,7 +1356,7 @@
           <a:lstStyle/>
           <a:p>
             <a:r>
-              <a:t>On the adult test set (70-80 y) the FAI shows substantial agreement with the WHO PTA-4 reference (kappa 0.68, Spearman 0.83) and matches the crisp grade on 88.2% of clear cases. 61.4% of adult ears sit within 5 dB of a severity boundary; there the system deliberately returns graded membership (58.7% agreement with the crisp label) rather than forcing a binary choice. The ML comparators regress PTA-4 itself and are reference-in-disguise, not independent benchmarks.</a:t>
+              <a:t>On the combined 20-69 y test set the FAI shows substantial agreement with the WHO PTA-4 reference (kappa 0.73, Spearman 0.58) and matches the crisp grade on 96.9% of clear cases. 18.8% of test ears sit within 5 dB of a severity boundary; there the system returns graded membership (70.6% agreement with the crisp label) rather than forcing a binary choice. Spearman is attenuated by range restriction (88.6% normal). The ML comparators regress PTA-4 itself and are reference-in-disguise, not independent benchmarks.</a:t>
             </a:r>
           </a:p>
         </p:txBody>
@@ -6290,7 +6290,7 @@
                 </a:solidFill>
                 <a:latin typeface="Calibri"/>
               </a:rPr>
-              <a:t>Configuration distribution, adult cohort (slope = 4 kHz − 500 Hz)</a:t>
+              <a:t>Configuration distribution, combined adult cohort (slope = 4 kHz − 500 Hz)</a:t>
             </a:r>
           </a:p>
         </p:txBody>
@@ -6371,7 +6371,7 @@
                 </a:solidFill>
                 <a:latin typeface="Georgia"/>
               </a:rPr>
-              <a:t>Steeply 31.8% · Gently sloping 29.7%</a:t>
+              <a:t>Flat 56.7% · Gently sloping 18.0%</a:t>
             </a:r>
           </a:p>
         </p:txBody>
@@ -6406,7 +6406,7 @@
                 </a:solidFill>
                 <a:latin typeface="Calibri"/>
               </a:rPr>
-              <a:t>dominant adult configurations (4 kHz − 500 Hz)</a:t>
+              <a:t>dominant configurations (4 kHz − 500 Hz)</a:t>
             </a:r>
           </a:p>
         </p:txBody>
@@ -6487,7 +6487,7 @@
                 </a:solidFill>
                 <a:latin typeface="Georgia"/>
               </a:rPr>
-              <a:t>Flat 22.0% · Precipitous 13.4% · Rising 3.1%</a:t>
+              <a:t>Steeply 8.8% · Precipitous 3.5% · Rising 13.0%</a:t>
             </a:r>
           </a:p>
         </p:txBody>
@@ -6719,7 +6719,7 @@
                 </a:solidFill>
                 <a:latin typeface="Georgia"/>
               </a:rPr>
-              <a:t>6.7% of participants</a:t>
+              <a:t>5.1% of participants</a:t>
             </a:r>
           </a:p>
         </p:txBody>
@@ -13261,7 +13261,7 @@
                 </a:solidFill>
                 <a:latin typeface="Calibri"/>
               </a:rPr>
-              <a:t>•  Adults-only cohort: 1,493 participants aged 70–80 y (NHANES protocol)</a:t>
+              <a:t>•  Adults 20–69 y: 3 NHANES cycles (1999-2000, 2011-12, 2015-16), n = 10,889</a:t>
             </a:r>
           </a:p>
           <a:p>
@@ -13280,7 +13280,7 @@
                 </a:solidFill>
                 <a:latin typeface="Calibri"/>
               </a:rPr>
-              <a:t>•  80/20 ear-level split: 1,584 training / 396 held-out test ears</a:t>
+              <a:t>•  80/20 ear-level split: 15,654 training / 3,914 held-out test ears</a:t>
             </a:r>
           </a:p>
           <a:p>
@@ -16021,7 +16021,7 @@
                           </a:solidFill>
                           <a:latin typeface="Calibri"/>
                         </a:rPr>
-                        <a:t>0.68</a:t>
+                        <a:t>0.73</a:t>
                       </a:r>
                     </a:p>
                   </a:txBody>
@@ -16044,7 +16044,7 @@
                           </a:solidFill>
                           <a:latin typeface="Calibri"/>
                         </a:rPr>
-                        <a:t>58.7%</a:t>
+                        <a:t>70.6%</a:t>
                       </a:r>
                     </a:p>
                   </a:txBody>
@@ -16067,7 +16067,7 @@
                           </a:solidFill>
                           <a:latin typeface="Calibri"/>
                         </a:rPr>
-                        <a:t>88.2%</a:t>
+                        <a:t>96.9%</a:t>
                       </a:r>
                     </a:p>
                   </a:txBody>
@@ -16621,7 +16621,7 @@
                 </a:solidFill>
                 <a:latin typeface="Georgia"/>
               </a:rPr>
-              <a:t>κ = 0.68</a:t>
+              <a:t>κ = 0.73</a:t>
             </a:r>
           </a:p>
         </p:txBody>
@@ -16656,7 +16656,7 @@
                 </a:solidFill>
                 <a:latin typeface="Calibri"/>
               </a:rPr>
-              <a:t>vs WHO PTA-4 reference, adult test</a:t>
+              <a:t>vs WHO PTA-4 reference, 20–69 y test</a:t>
             </a:r>
           </a:p>
         </p:txBody>
@@ -16737,7 +16737,7 @@
                 </a:solidFill>
                 <a:latin typeface="Georgia"/>
               </a:rPr>
-              <a:t>ρ = 0.83 · MAE 10.5 dB</a:t>
+              <a:t>ρ = 0.58 · MAE 6.1 dB</a:t>
             </a:r>
           </a:p>
         </p:txBody>
@@ -16772,7 +16772,7 @@
                 </a:solidFill>
                 <a:latin typeface="Calibri"/>
               </a:rPr>
-              <a:t>FAI vs PTA-4, adult test (n = 396)</a:t>
+              <a:t>FAI vs PTA-4, n = 3,914 test ears</a:t>
             </a:r>
           </a:p>
         </p:txBody>
@@ -17838,7 +17838,7 @@
                 </a:solidFill>
                 <a:latin typeface="Calibri"/>
               </a:rPr>
-              <a:t>The fuzzy system deviates from crisp labels in the borderline zone (agreement 47–59% within ±1–5 dB) while matching crisp in clear cases (88.2%)</a:t>
+              <a:t>The fuzzy system deviates from crisp labels in the borderline zone (agreement 63–72% within ±1–5 dB) while matching crisp in clear cases (96.9%)</a:t>
             </a:r>
           </a:p>
         </p:txBody>
@@ -18027,7 +18027,7 @@
         <p:spPr>
           <a:xfrm>
             <a:off x="502920" y="1188720"/>
-            <a:ext cx="5532120" cy="4840273"/>
+            <a:ext cx="5532120" cy="4860267"/>
           </a:xfrm>
           <a:prstGeom prst="rect">
             <a:avLst/>
@@ -18042,7 +18042,7 @@
         </p:nvSpPr>
         <p:spPr>
           <a:xfrm>
-            <a:off x="502920" y="6083857"/>
+            <a:off x="502920" y="6103851"/>
             <a:ext cx="5532120" cy="274320"/>
           </a:xfrm>
           <a:prstGeom prst="rect">

</xml_diff>

<commit_message>
Fold re-optimised-MF pipeline results into the submission package
Primary metrics now the optimised-MF run on the combined 20-69y cohort:
kappa 0.76, overall 91.4%, clear 95.2%, borderline 74.9%, MAE 6.0 dB,
rho 0.61, Bland-Altman bias -0.9 (LoA -16.1..+14.3, n=3,914).

- MFs re-optimised on combined training set (params_combined.json); docs
  disclose deployed webapp still ships the 2017-2020 fit
- Boundary table, case studies A-D, and all figures regenerated with new MFs
- Removed stale Discussion claim 'fuzzy outperformed XGBoost 91% vs 79%'
- Deck: fixed stale ML rows (0.85/79.1%), heuristic boundary table, and
  '5,147 participants' chips -> 10,889 / 3 cycles
- Report Data Source + MF optimisation sections rewritten for combined cohort
- All PDFs text-verified clean
</commit_message>
<xml_diff>
--- a/arabcic2026/arabcic2026_fuzzy_audiogram.pptx
+++ b/arabcic2026/arabcic2026_fuzzy_audiogram.pptx
@@ -516,7 +516,7 @@
           <a:lstStyle/>
           <a:p>
             <a:r>
-              <a:t>Good morning. Hearing loss classification has barely changed since Goodman in 1965. This talk presents a fuzzy logic framework that preserves the diagnostic gradation that crisp WHO thresholds discard, validated on NHANES 2017-2020.</a:t>
+              <a:t>Good morning. Hearing loss classification has barely changed since Goodman in 1965. This talk presents a fuzzy logic framework that preserves the diagnostic gradation that crisp WHO thresholds discard, validated on three NHANES adult cycles (20–69 y).</a:t>
             </a:r>
           </a:p>
         </p:txBody>
@@ -866,7 +866,7 @@
           <a:lstStyle/>
           <a:p>
             <a:r>
-              <a:t>Three messages: the FAI preserves gradation, it beats crisp and ML comparators precisely where decisions are hardest, and it stays interpretable throughout.</a:t>
+              <a:t>Three messages: the FAI preserves gradation, it deliberately reclassifies borderline cases where crisp labels force a binary choice, and it stays interpretable throughout.</a:t>
             </a:r>
           </a:p>
         </p:txBody>
@@ -1146,7 +1146,7 @@
           <a:lstStyle/>
           <a:p>
             <a:r>
-              <a:t>We used NHANES 2017-2020, 5,147 adults with complete air-conduction thresholds. An 80/20 stratified split keeps every WHO category in both partitions, and everything is optimised on training and reported on the held-out test set. Comparators are the WHO PTA-4 rules, XGBoost and Random Forest.</a:t>
+              <a:t>We combined three NHANES cycles that tested adults 20-69 y (10,889 participants; 19,568 clean ears). An 80/20 stratified split keeps every WHO category in both partitions, and everything is optimised on training and reported on the held-out test set. Comparators are the WHO PTA-4 rules, XGBoost and Random Forest.</a:t>
             </a:r>
           </a:p>
         </p:txBody>
@@ -1216,7 +1216,7 @@
           <a:lstStyle/>
           <a:p>
             <a:r>
-              <a:t>Each frequency band has six overlapping trapezoidal membership functions. The optimised parameters sit a few dB to the right of the classic WHO cutoffs, with 2-3 dB of overlap, so a 27 dB threshold is simultaneously 7% normal and 25% mild.</a:t>
+              <a:t>Each frequency band has six overlapping trapezoidal membership functions. The optimised parameters sit a few dB to the right of the classic WHO cutoffs, with exactly 2 dB of overlap, so a 26 dB threshold is simultaneously 16% normal and 40% mild.</a:t>
             </a:r>
           </a:p>
         </p:txBody>
@@ -1356,7 +1356,7 @@
           <a:lstStyle/>
           <a:p>
             <a:r>
-              <a:t>On the combined 20-69 y test set the FAI shows substantial agreement with the WHO PTA-4 reference (kappa 0.73, Spearman 0.58) and matches the crisp grade on 96.9% of clear cases. 18.8% of test ears sit within 5 dB of a severity boundary; there the system returns graded membership (70.6% agreement with the crisp label) rather than forcing a binary choice. Spearman is attenuated by range restriction (88.6% normal). The ML comparators regress PTA-4 itself and are reference-in-disguise, not independent benchmarks.</a:t>
+              <a:t>On the combined 20-69 y test set the FAI shows substantial agreement with the WHO PTA-4 reference (kappa 0.76, Spearman 0.61) and matches the crisp grade on 95.2% of clear cases. 18.8% of test ears sit within 5 dB of a severity boundary; there the system returns graded membership (74.9% agreement with the crisp label) rather than forcing a binary choice. Spearman is attenuated by range restriction (88.6% normal). The ML comparators regress PTA-4 itself and are reference-in-disguise, not independent benchmarks.</a:t>
             </a:r>
           </a:p>
         </p:txBody>
@@ -1426,7 +1426,7 @@
           <a:lstStyle/>
           <a:p>
             <a:r>
-              <a:t>This is the clinical core. At the normal-mild boundary the fuzzy system reports graded membership instead of a forced binary label; it matches the crisp label in clear cases (94.2%) while deliberately deviating from it in the borderline zone (agreement 53–63% within ±1–3 dB).</a:t>
+              <a:t>This is the clinical core. At the normal-mild boundary the fuzzy system reports graded membership instead of a forced binary label; it matches the crisp label in clear cases (95.2%) while deliberately deviating from it in the borderline zone (agreement 59–70% within ±1–3 dB).</a:t>
             </a:r>
           </a:p>
         </p:txBody>
@@ -5793,7 +5793,7 @@
                 </a:solidFill>
                 <a:latin typeface="Georgia"/>
               </a:rPr>
-              <a:t>5,147</a:t>
+              <a:t>10,889</a:t>
             </a:r>
           </a:p>
         </p:txBody>
@@ -5828,7 +5828,7 @@
                 </a:solidFill>
                 <a:latin typeface="Calibri"/>
               </a:rPr>
-              <a:t>NHANES 2017–2020 participants</a:t>
+              <a:t>adults 20–69 y · 3 NHANES cycles</a:t>
             </a:r>
           </a:p>
         </p:txBody>
@@ -9900,7 +9900,7 @@
                 </a:solidFill>
                 <a:latin typeface="Calibri"/>
               </a:rPr>
-              <a:t>κ = 0.69 against WHO PTA-4; 94.2% agreement in clear cases, with deliberate graded reclassification in the borderline zone (56.3%).</a:t>
+              <a:t>κ = 0.76 against WHO PTA-4; 95.2% agreement in clear cases, with deliberate graded reclassification in the borderline zone (74.9%).</a:t>
             </a:r>
           </a:p>
         </p:txBody>
@@ -12838,7 +12838,7 @@
                 </a:solidFill>
                 <a:latin typeface="Calibri"/>
               </a:rPr>
-              <a:t>Overlapping trapezoidal functions at each boundary (2–3 dB overlap)</a:t>
+              <a:t>Overlapping trapezoidal functions at each boundary (2.0 dB overlap)</a:t>
             </a:r>
           </a:p>
           <a:p>
@@ -13219,7 +13219,7 @@
                 </a:solidFill>
                 <a:latin typeface="Georgia"/>
               </a:rPr>
-              <a:t>Data: NHANES 2017–2020</a:t>
+              <a:t>Data: 3 NHANES adult cycles</a:t>
             </a:r>
           </a:p>
         </p:txBody>
@@ -13634,7 +13634,7 @@
         <p:spPr>
           <a:xfrm>
             <a:off x="502920" y="1234440"/>
-            <a:ext cx="5943600" cy="3233751"/>
+            <a:ext cx="5943600" cy="3534846"/>
           </a:xfrm>
           <a:prstGeom prst="rect">
             <a:avLst/>
@@ -13649,7 +13649,7 @@
         </p:nvSpPr>
         <p:spPr>
           <a:xfrm>
-            <a:off x="502920" y="4559631"/>
+            <a:off x="502920" y="4860726"/>
             <a:ext cx="5943600" cy="548640"/>
           </a:xfrm>
           <a:prstGeom prst="rect">
@@ -13957,7 +13957,7 @@
                           </a:solidFill>
                           <a:latin typeface="Calibri"/>
                         </a:rPr>
-                        <a:t>0.4</a:t>
+                        <a:t>0.0</a:t>
                       </a:r>
                     </a:p>
                   </a:txBody>
@@ -13980,7 +13980,7 @@
                           </a:solidFill>
                           <a:latin typeface="Calibri"/>
                         </a:rPr>
-                        <a:t>5.0</a:t>
+                        <a:t>6.4</a:t>
                       </a:r>
                     </a:p>
                   </a:txBody>
@@ -14003,7 +14003,7 @@
                           </a:solidFill>
                           <a:latin typeface="Calibri"/>
                         </a:rPr>
-                        <a:t>14.3</a:t>
+                        <a:t>16.4</a:t>
                       </a:r>
                     </a:p>
                   </a:txBody>
@@ -14026,7 +14026,7 @@
                           </a:solidFill>
                           <a:latin typeface="Calibri"/>
                         </a:rPr>
-                        <a:t>26.3</a:t>
+                        <a:t>27.8</a:t>
                       </a:r>
                     </a:p>
                   </a:txBody>
@@ -14074,7 +14074,7 @@
                           </a:solidFill>
                           <a:latin typeface="Calibri"/>
                         </a:rPr>
-                        <a:t>28.0</a:t>
+                        <a:t>25.8</a:t>
                       </a:r>
                     </a:p>
                   </a:txBody>
@@ -14097,7 +14097,7 @@
                           </a:solidFill>
                           <a:latin typeface="Calibri"/>
                         </a:rPr>
-                        <a:t>30.0</a:t>
+                        <a:t>26.3</a:t>
                       </a:r>
                     </a:p>
                   </a:txBody>
@@ -14120,7 +14120,7 @@
                           </a:solidFill>
                           <a:latin typeface="Calibri"/>
                         </a:rPr>
-                        <a:t>39.3</a:t>
+                        <a:t>36.4</a:t>
                       </a:r>
                     </a:p>
                   </a:txBody>
@@ -14143,7 +14143,7 @@
                           </a:solidFill>
                           <a:latin typeface="Calibri"/>
                         </a:rPr>
-                        <a:t>42.0</a:t>
+                        <a:t>43.5</a:t>
                       </a:r>
                     </a:p>
                   </a:txBody>
@@ -14191,7 +14191,7 @@
                           </a:solidFill>
                           <a:latin typeface="Calibri"/>
                         </a:rPr>
-                        <a:t>43.0</a:t>
+                        <a:t>41.5</a:t>
                       </a:r>
                     </a:p>
                   </a:txBody>
@@ -14214,7 +14214,7 @@
                           </a:solidFill>
                           <a:latin typeface="Calibri"/>
                         </a:rPr>
-                        <a:t>45.0</a:t>
+                        <a:t>42.0</a:t>
                       </a:r>
                     </a:p>
                   </a:txBody>
@@ -14237,7 +14237,7 @@
                           </a:solidFill>
                           <a:latin typeface="Calibri"/>
                         </a:rPr>
-                        <a:t>53.6</a:t>
+                        <a:t>54.3</a:t>
                       </a:r>
                     </a:p>
                   </a:txBody>
@@ -14260,7 +14260,7 @@
                           </a:solidFill>
                           <a:latin typeface="Calibri"/>
                         </a:rPr>
-                        <a:t>57.0</a:t>
+                        <a:t>58.5</a:t>
                       </a:r>
                     </a:p>
                   </a:txBody>
@@ -14308,7 +14308,7 @@
                           </a:solidFill>
                           <a:latin typeface="Calibri"/>
                         </a:rPr>
-                        <a:t>58.0</a:t>
+                        <a:t>56.5</a:t>
                       </a:r>
                     </a:p>
                   </a:txBody>
@@ -14331,7 +14331,7 @@
                           </a:solidFill>
                           <a:latin typeface="Calibri"/>
                         </a:rPr>
-                        <a:t>60.0</a:t>
+                        <a:t>57.0</a:t>
                       </a:r>
                     </a:p>
                   </a:txBody>
@@ -14377,7 +14377,7 @@
                           </a:solidFill>
                           <a:latin typeface="Calibri"/>
                         </a:rPr>
-                        <a:t>72.0</a:t>
+                        <a:t>73.5</a:t>
                       </a:r>
                     </a:p>
                   </a:txBody>
@@ -14425,7 +14425,7 @@
                           </a:solidFill>
                           <a:latin typeface="Calibri"/>
                         </a:rPr>
-                        <a:t>73.0</a:t>
+                        <a:t>71.5</a:t>
                       </a:r>
                     </a:p>
                   </a:txBody>
@@ -14448,7 +14448,7 @@
                           </a:solidFill>
                           <a:latin typeface="Calibri"/>
                         </a:rPr>
-                        <a:t>75.0</a:t>
+                        <a:t>72.0</a:t>
                       </a:r>
                     </a:p>
                   </a:txBody>
@@ -14471,7 +14471,7 @@
                           </a:solidFill>
                           <a:latin typeface="Calibri"/>
                         </a:rPr>
-                        <a:t>85.4</a:t>
+                        <a:t>83.7</a:t>
                       </a:r>
                     </a:p>
                   </a:txBody>
@@ -14494,7 +14494,7 @@
                           </a:solidFill>
                           <a:latin typeface="Calibri"/>
                         </a:rPr>
-                        <a:t>92.0</a:t>
+                        <a:t>93.0</a:t>
                       </a:r>
                     </a:p>
                   </a:txBody>
@@ -14542,7 +14542,7 @@
                           </a:solidFill>
                           <a:latin typeface="Calibri"/>
                         </a:rPr>
-                        <a:t>91.9</a:t>
+                        <a:t>91.0</a:t>
                       </a:r>
                     </a:p>
                   </a:txBody>
@@ -14565,7 +14565,7 @@
                           </a:solidFill>
                           <a:latin typeface="Calibri"/>
                         </a:rPr>
-                        <a:t>94.4</a:t>
+                        <a:t>91.5</a:t>
                       </a:r>
                     </a:p>
                   </a:txBody>
@@ -14588,7 +14588,7 @@
                           </a:solidFill>
                           <a:latin typeface="Calibri"/>
                         </a:rPr>
-                        <a:t>103.5</a:t>
+                        <a:t>104.6</a:t>
                       </a:r>
                     </a:p>
                   </a:txBody>
@@ -14746,7 +14746,7 @@
                 </a:solidFill>
                 <a:latin typeface="Calibri"/>
               </a:rPr>
-              <a:t>2–3 dB overlap at each classic WHO boundary → smooth transitions</a:t>
+              <a:t>Exactly 2.0 dB overlap at each WHO boundary → smooth transitions</a:t>
             </a:r>
           </a:p>
           <a:p>
@@ -14762,7 +14762,7 @@
                 </a:solidFill>
                 <a:latin typeface="Calibri"/>
               </a:rPr>
-              <a:t>27 dB HL → </a:t>
+              <a:t>26 dB HL → </a:t>
             </a:r>
             <a:r>
               <a:rPr sz="1200" b="1" i="0">
@@ -14771,7 +14771,7 @@
                 </a:solidFill>
                 <a:latin typeface="Calibri"/>
               </a:rPr>
-              <a:t>Normal μ 0.07</a:t>
+              <a:t>Normal μ 0.16</a:t>
             </a:r>
             <a:r>
               <a:rPr sz="1200" b="0" i="0">
@@ -14789,7 +14789,7 @@
                 </a:solidFill>
                 <a:latin typeface="Calibri"/>
               </a:rPr>
-              <a:t>Mild μ 0.25</a:t>
+              <a:t>Mild μ 0.40</a:t>
             </a:r>
             <a:r>
               <a:rPr sz="1200" b="0" i="0">
@@ -16021,7 +16021,7 @@
                           </a:solidFill>
                           <a:latin typeface="Calibri"/>
                         </a:rPr>
-                        <a:t>0.73</a:t>
+                        <a:t>0.76</a:t>
                       </a:r>
                     </a:p>
                   </a:txBody>
@@ -16044,7 +16044,7 @@
                           </a:solidFill>
                           <a:latin typeface="Calibri"/>
                         </a:rPr>
-                        <a:t>70.6%</a:t>
+                        <a:t>74.9%</a:t>
                       </a:r>
                     </a:p>
                   </a:txBody>
@@ -16067,7 +16067,7 @@
                           </a:solidFill>
                           <a:latin typeface="Calibri"/>
                         </a:rPr>
-                        <a:t>96.9%</a:t>
+                        <a:t>95.2%</a:t>
                       </a:r>
                     </a:p>
                   </a:txBody>
@@ -16209,7 +16209,7 @@
                           </a:solidFill>
                           <a:latin typeface="Calibri"/>
                         </a:rPr>
-                        <a:t>0.85</a:t>
+                        <a:t>0.98</a:t>
                       </a:r>
                     </a:p>
                   </a:txBody>
@@ -16232,7 +16232,7 @@
                           </a:solidFill>
                           <a:latin typeface="Calibri"/>
                         </a:rPr>
-                        <a:t>79.1%</a:t>
+                        <a:t>93.5%</a:t>
                       </a:r>
                     </a:p>
                   </a:txBody>
@@ -16255,7 +16255,7 @@
                           </a:solidFill>
                           <a:latin typeface="Calibri"/>
                         </a:rPr>
-                        <a:t>92.2%</a:t>
+                        <a:t>100%</a:t>
                       </a:r>
                     </a:p>
                   </a:txBody>
@@ -16303,7 +16303,7 @@
                           </a:solidFill>
                           <a:latin typeface="Calibri"/>
                         </a:rPr>
-                        <a:t>0.83</a:t>
+                        <a:t>0.98</a:t>
                       </a:r>
                     </a:p>
                   </a:txBody>
@@ -16326,7 +16326,7 @@
                           </a:solidFill>
                           <a:latin typeface="Calibri"/>
                         </a:rPr>
-                        <a:t>76.3%</a:t>
+                        <a:t>93.8%</a:t>
                       </a:r>
                     </a:p>
                   </a:txBody>
@@ -16349,7 +16349,7 @@
                           </a:solidFill>
                           <a:latin typeface="Calibri"/>
                         </a:rPr>
-                        <a:t>90.4%</a:t>
+                        <a:t>100%</a:t>
                       </a:r>
                     </a:p>
                   </a:txBody>
@@ -16481,7 +16481,7 @@
                 </a:solidFill>
                 <a:latin typeface="Calibri"/>
               </a:rPr>
-              <a:t>In borderline cases (±5 dB), the fuzzy system deliberately reclassifies (56.3% agree with the crisp grade) while matching it in clear cases (94.2%).</a:t>
+              <a:t>In borderline cases (±5 dB), the fuzzy system deliberately reclassifies (74.9% agree with the crisp grade) while matching it in clear cases (95.2%).</a:t>
             </a:r>
           </a:p>
         </p:txBody>
@@ -16503,7 +16503,7 @@
         <p:spPr>
           <a:xfrm>
             <a:off x="7726679" y="1234440"/>
-            <a:ext cx="3977639" cy="2966803"/>
+            <a:ext cx="3977639" cy="2789575"/>
           </a:xfrm>
           <a:prstGeom prst="rect">
             <a:avLst/>
@@ -16518,7 +16518,7 @@
         </p:nvSpPr>
         <p:spPr>
           <a:xfrm>
-            <a:off x="7726679" y="4274395"/>
+            <a:off x="7726679" y="4097167"/>
             <a:ext cx="3977639" cy="320040"/>
           </a:xfrm>
           <a:prstGeom prst="rect">
@@ -16621,7 +16621,7 @@
                 </a:solidFill>
                 <a:latin typeface="Georgia"/>
               </a:rPr>
-              <a:t>κ = 0.73</a:t>
+              <a:t>κ = 0.76</a:t>
             </a:r>
           </a:p>
         </p:txBody>
@@ -16737,7 +16737,7 @@
                 </a:solidFill>
                 <a:latin typeface="Georgia"/>
               </a:rPr>
-              <a:t>ρ = 0.58 · MAE 6.1 dB</a:t>
+              <a:t>ρ = 0.61 · MAE 6.0 dB</a:t>
             </a:r>
           </a:p>
         </p:txBody>
@@ -17193,7 +17193,7 @@
                           </a:solidFill>
                           <a:latin typeface="Calibri"/>
                         </a:rPr>
-                        <a:t>19.0</a:t>
+                        <a:t>9.3</a:t>
                       </a:r>
                     </a:p>
                   </a:txBody>
@@ -17216,7 +17216,7 @@
                           </a:solidFill>
                           <a:latin typeface="Calibri"/>
                         </a:rPr>
-                        <a:t>0.60</a:t>
+                        <a:t>0.33</a:t>
                       </a:r>
                     </a:p>
                   </a:txBody>
@@ -17239,7 +17239,7 @@
                           </a:solidFill>
                           <a:latin typeface="Calibri"/>
                         </a:rPr>
-                        <a:t>0.67</a:t>
+                        <a:t>0.00</a:t>
                       </a:r>
                     </a:p>
                   </a:txBody>
@@ -17310,7 +17310,7 @@
                           </a:solidFill>
                           <a:latin typeface="Calibri"/>
                         </a:rPr>
-                        <a:t>Mild</a:t>
+                        <a:t>Normal</a:t>
                       </a:r>
                     </a:p>
                   </a:txBody>
@@ -17333,7 +17333,7 @@
                           </a:solidFill>
                           <a:latin typeface="Calibri"/>
                         </a:rPr>
-                        <a:t>23.1</a:t>
+                        <a:t>9.3</a:t>
                       </a:r>
                     </a:p>
                   </a:txBody>
@@ -17356,7 +17356,7 @@
                           </a:solidFill>
                           <a:latin typeface="Calibri"/>
                         </a:rPr>
-                        <a:t>0.50</a:t>
+                        <a:t>0.25</a:t>
                       </a:r>
                     </a:p>
                   </a:txBody>
@@ -17379,7 +17379,7 @@
                           </a:solidFill>
                           <a:latin typeface="Calibri"/>
                         </a:rPr>
-                        <a:t>0.83</a:t>
+                        <a:t>0.00</a:t>
                       </a:r>
                     </a:p>
                   </a:txBody>
@@ -17450,7 +17450,7 @@
                           </a:solidFill>
                           <a:latin typeface="Calibri"/>
                         </a:rPr>
-                        <a:t>Mild</a:t>
+                        <a:t>Normal</a:t>
                       </a:r>
                     </a:p>
                   </a:txBody>
@@ -17473,7 +17473,30 @@
                           </a:solidFill>
                           <a:latin typeface="Calibri"/>
                         </a:rPr>
-                        <a:t>24.6</a:t>
+                        <a:t>16.8</a:t>
+                      </a:r>
+                    </a:p>
+                  </a:txBody>
+                  <a:tcPr marL="76200" marR="76200" marT="25400" marB="25400" anchor="ctr">
+                    <a:solidFill>
+                      <a:srgbClr val="FBF3E0"/>
+                    </a:solidFill>
+                  </a:tcPr>
+                </a:tc>
+                <a:tc>
+                  <a:txBody>
+                    <a:bodyPr wrap="square"/>
+                    <a:lstStyle/>
+                    <a:p>
+                      <a:pPr algn="ctr"/>
+                      <a:r>
+                        <a:rPr sz="1100" b="0">
+                          <a:solidFill>
+                            <a:srgbClr val="1B2A3A"/>
+                          </a:solidFill>
+                          <a:latin typeface="Calibri"/>
+                        </a:rPr>
+                        <a:t>0.16</a:t>
                       </a:r>
                     </a:p>
                   </a:txBody>
@@ -17497,29 +17520,6 @@
                           <a:latin typeface="Calibri"/>
                         </a:rPr>
                         <a:t>0.40</a:t>
-                      </a:r>
-                    </a:p>
-                  </a:txBody>
-                  <a:tcPr marL="76200" marR="76200" marT="25400" marB="25400" anchor="ctr">
-                    <a:solidFill>
-                      <a:srgbClr val="FBF3E0"/>
-                    </a:solidFill>
-                  </a:tcPr>
-                </a:tc>
-                <a:tc>
-                  <a:txBody>
-                    <a:bodyPr wrap="square"/>
-                    <a:lstStyle/>
-                    <a:p>
-                      <a:pPr algn="ctr"/>
-                      <a:r>
-                        <a:rPr sz="1100" b="0">
-                          <a:solidFill>
-                            <a:srgbClr val="1B2A3A"/>
-                          </a:solidFill>
-                          <a:latin typeface="Calibri"/>
-                        </a:rPr>
-                        <a:t>1.00</a:t>
                       </a:r>
                     </a:p>
                   </a:txBody>
@@ -17613,7 +17613,7 @@
                           </a:solidFill>
                           <a:latin typeface="Calibri"/>
                         </a:rPr>
-                        <a:t>30.0</a:t>
+                        <a:t>20.4</a:t>
                       </a:r>
                     </a:p>
                   </a:txBody>
@@ -17759,7 +17759,7 @@
                 </a:solidFill>
                 <a:latin typeface="Calibri"/>
               </a:rPr>
-              <a:t>A patient with PTA 24 dB is simultaneously 60% normal and 67% mild — the crisp label hides this ambiguity.</a:t>
+              <a:t>A patient with PTA 26 dB is simultaneously 16% normal and 40% mild — the crisp label hides this ambiguity.</a:t>
             </a:r>
           </a:p>
           <a:p>
@@ -17775,7 +17775,7 @@
                 </a:solidFill>
                 <a:latin typeface="Calibri"/>
               </a:rPr>
-              <a:t>FAI rises smoothly from 19.0 to 30.0; crisp rules impose a step at 26 dB.</a:t>
+              <a:t>FAI rises smoothly from 9.3 at 24 dB to 20.4 at 30 dB; crisp rules impose a step at 26 dB.</a:t>
             </a:r>
           </a:p>
         </p:txBody>
@@ -17838,7 +17838,7 @@
                 </a:solidFill>
                 <a:latin typeface="Calibri"/>
               </a:rPr>
-              <a:t>The fuzzy system deviates from crisp labels in the borderline zone (agreement 63–72% within ±1–5 dB) while matching crisp in clear cases (96.9%)</a:t>
+              <a:t>The fuzzy system deviates from crisp labels in the borderline zone (agreement 59–75% within ±1–5 dB) while matching crisp in clear cases (95.2%)</a:t>
             </a:r>
           </a:p>
         </p:txBody>
@@ -18163,7 +18163,7 @@
                 </a:solidFill>
                 <a:latin typeface="Calibri"/>
               </a:rPr>
-              <a:t>PTA 27.5 dB “Mild” · FAI 26.3</a:t>
+              <a:t>PTA 27.5 dB “Mild” · FAI 20.4</a:t>
             </a:r>
           </a:p>
           <a:p>
@@ -18182,7 +18182,7 @@
                 </a:solidFill>
                 <a:latin typeface="Calibri"/>
               </a:rPr>
-              <a:t>Normal μ 0.25, Mild μ 1.00 — graded, not forced</a:t>
+              <a:t>Normal μ 0.04, Mild μ 1.00 — graded, not forced</a:t>
             </a:r>
           </a:p>
         </p:txBody>
@@ -18399,7 +18399,7 @@
                 </a:solidFill>
                 <a:latin typeface="Calibri"/>
               </a:rPr>
-              <a:t>PTA 33.8 dB “Mild” · FAI 30.0</a:t>
+              <a:t>PTA 33.8 dB “Mild” · FAI 20.4</a:t>
             </a:r>
           </a:p>
           <a:p>
@@ -18536,7 +18536,7 @@
                 </a:solidFill>
                 <a:latin typeface="Calibri"/>
               </a:rPr>
-              <a:t>Left FAI 42.2 after adjustment — impact quantified</a:t>
+              <a:t>Composite FAI 54.5 (Mod-Sev) — impact quantified</a:t>
             </a:r>
           </a:p>
         </p:txBody>

</xml_diff>